<commit_message>
Add LDA model and update project results
This change adds Linear Discriminant Analysis as a fifth benchmark model and wires it into the shared evaluation pipeline. It updates the preprocessing setup to use dense one-hot encoding for compatibility with LDA, refreshes the comparison script and result summaries, and includes the new LDA metrics in the README and generated outputs. The project now reports a five-model comparison with refreshed charts, CSV summaries, and JSON result files.
</commit_message>
<xml_diff>
--- a/Report/Mini project report.pptx
+++ b/Report/Mini project report.pptx
@@ -137,7 +137,7 @@
   <pc:docChgLst>
     <pc:chgData name="David Irungu" userId="3570a5346c53ff8c" providerId="LiveId" clId="{B3EF4350-6A02-4366-A4A5-47E00D9EF2BB}"/>
     <pc:docChg chg="undo custSel addSld modSld">
-      <pc:chgData name="David Irungu" userId="3570a5346c53ff8c" providerId="LiveId" clId="{B3EF4350-6A02-4366-A4A5-47E00D9EF2BB}" dt="2026-08-22T12:00:29.323" v="853" actId="20577"/>
+      <pc:chgData name="David Irungu" userId="3570a5346c53ff8c" providerId="LiveId" clId="{B3EF4350-6A02-4366-A4A5-47E00D9EF2BB}" dt="2026-08-22T12:53:19.731" v="861" actId="20577"/>
       <pc:docMkLst>
         <pc:docMk/>
       </pc:docMkLst>
@@ -165,13 +165,13 @@
         </pc:spChg>
       </pc:sldChg>
       <pc:sldChg chg="delSp modSp mod">
-        <pc:chgData name="David Irungu" userId="3570a5346c53ff8c" providerId="LiveId" clId="{B3EF4350-6A02-4366-A4A5-47E00D9EF2BB}" dt="2026-08-22T11:46:42.683" v="736" actId="20577"/>
+        <pc:chgData name="David Irungu" userId="3570a5346c53ff8c" providerId="LiveId" clId="{B3EF4350-6A02-4366-A4A5-47E00D9EF2BB}" dt="2026-08-22T12:50:46.303" v="860" actId="20577"/>
         <pc:sldMkLst>
           <pc:docMk/>
           <pc:sldMk cId="0" sldId="257"/>
         </pc:sldMkLst>
         <pc:spChg chg="mod">
-          <ac:chgData name="David Irungu" userId="3570a5346c53ff8c" providerId="LiveId" clId="{B3EF4350-6A02-4366-A4A5-47E00D9EF2BB}" dt="2026-08-22T11:46:42.683" v="736" actId="20577"/>
+          <ac:chgData name="David Irungu" userId="3570a5346c53ff8c" providerId="LiveId" clId="{B3EF4350-6A02-4366-A4A5-47E00D9EF2BB}" dt="2026-08-22T12:50:46.303" v="860" actId="20577"/>
           <ac:spMkLst>
             <pc:docMk/>
             <pc:sldMk cId="0" sldId="257"/>
@@ -657,7 +657,7 @@
         </pc:spChg>
       </pc:sldChg>
       <pc:sldChg chg="modSp mod">
-        <pc:chgData name="David Irungu" userId="3570a5346c53ff8c" providerId="LiveId" clId="{B3EF4350-6A02-4366-A4A5-47E00D9EF2BB}" dt="2026-08-22T11:28:30.262" v="339" actId="1076"/>
+        <pc:chgData name="David Irungu" userId="3570a5346c53ff8c" providerId="LiveId" clId="{B3EF4350-6A02-4366-A4A5-47E00D9EF2BB}" dt="2026-08-22T12:53:19.731" v="861" actId="20577"/>
         <pc:sldMkLst>
           <pc:docMk/>
           <pc:sldMk cId="0" sldId="261"/>
@@ -679,7 +679,7 @@
           </ac:spMkLst>
         </pc:spChg>
         <pc:spChg chg="mod">
-          <ac:chgData name="David Irungu" userId="3570a5346c53ff8c" providerId="LiveId" clId="{B3EF4350-6A02-4366-A4A5-47E00D9EF2BB}" dt="2026-08-22T11:28:30.262" v="339" actId="1076"/>
+          <ac:chgData name="David Irungu" userId="3570a5346c53ff8c" providerId="LiveId" clId="{B3EF4350-6A02-4366-A4A5-47E00D9EF2BB}" dt="2026-08-22T12:53:19.731" v="861" actId="20577"/>
           <ac:spMkLst>
             <pc:docMk/>
             <pc:sldMk cId="0" sldId="261"/>
@@ -11709,7 +11709,7 @@
               <a:t>A bank account lets people save safely, borrow, insure against risk and receive payments. Across sub-Saharan Africa, only about half of adults hold any account, and far fewer hold a formal bank account (</a:t>
             </a:r>
             <a:r>
-              <a:rPr lang="fi-FI" sz="1550" dirty="0">
+              <a:rPr lang="nl-NL" sz="1550" dirty="0">
                 <a:solidFill>
                   <a:srgbClr val="0B0B0B"/>
                 </a:solidFill>
@@ -11717,7 +11717,18 @@
                 <a:ea typeface="Calibri" pitchFamily="34" charset="-122"/>
                 <a:cs typeface="Calibri" pitchFamily="34" charset="-120"/>
               </a:rPr>
-              <a:t>Suri T., 2016)</a:t>
+              <a:t>Demirguc-Kunt et al, 2022</a:t>
+            </a:r>
+            <a:r>
+              <a:rPr lang="fi-FI" sz="1550" dirty="0">
+                <a:solidFill>
+                  <a:srgbClr val="0B0B0B"/>
+                </a:solidFill>
+                <a:latin typeface="Calibri" pitchFamily="34" charset="0"/>
+                <a:ea typeface="Calibri" pitchFamily="34" charset="-122"/>
+                <a:cs typeface="Calibri" pitchFamily="34" charset="-120"/>
+              </a:rPr>
+              <a:t>)</a:t>
             </a:r>
             <a:r>
               <a:rPr lang="en-US" sz="1550" dirty="0">
@@ -14603,7 +14614,7 @@
                 <a:ea typeface="Calibri" pitchFamily="34" charset="-122"/>
                 <a:cs typeface="Calibri" pitchFamily="34" charset="-120"/>
               </a:rPr>
-              <a:t>Always answering “No account” scores 85.9%; All 4 models beats the benchmark, but by at most 2.9 points.</a:t>
+              <a:t>Always answering “No account” scores 85.9%; All 4 models beat the benchmark, but by at most 2.9 points.</a:t>
             </a:r>
             <a:endParaRPr lang="en-US" sz="1250" dirty="0"/>
           </a:p>

</xml_diff>

<commit_message>
Update mini project report
Updated the mini project report presentation with LDA algorithm
</commit_message>
<xml_diff>
--- a/Report/Mini project report.pptx
+++ b/Report/Mini project report.pptx
@@ -1130,8 +1130,7 @@
           <a:lstStyle/>
           <a:p>
             <a:r>
-              <a:rPr lang="en-US" dirty="0"/>
-              <a:t>Binary classification task on survey data from Kenya, Rwanda, Tanzania and Uganda. Four classic algorithms are compared under an identical protocol: same preprocessing, same 2-fold stratified cross-validation.</a:t>
+              <a:t>Binary classification task on survey data from Kenya, Rwanda, Tanzania and Uganda. Five classic algorithms are compared under an identical protocol: same preprocessing, same 2-fold stratified cross-validation.</a:t>
             </a:r>
           </a:p>
         </p:txBody>
@@ -1415,8 +1414,7 @@
           <a:lstStyle/>
           <a:p>
             <a:r>
-              <a:rPr lang="en-US" dirty="0"/>
-              <a:t>Two strands of prior work: (1) financial-inclusion research establishing the problem's importance and its measurement; (2) ML literature comparing these same four algorithm families, which finds no universal winner - hence this experiment.</a:t>
+              <a:t>Two strands of prior work: (1) financial-inclusion research establishing the problem's importance and its measurement; (2) ML literature comparing these same five algorithm families, which finds no universal winner - hence this experiment.</a:t>
             </a:r>
           </a:p>
         </p:txBody>
@@ -1589,8 +1587,7 @@
           <a:lstStyle/>
           <a:p>
             <a:r>
-              <a:rPr lang="en-US" dirty="0"/>
-              <a:t>One card per algorithm with its key settings. Class weighting was deliberately not used on the tree and SVM because KNN and the ANN have no equivalent - keeping the comparison fair.</a:t>
+              <a:t>One card per algorithm (five in total) with its key settings. Class weighting was deliberately not used on the tree and SVM because KNN and the ANN have no equivalent - keeping the comparison fair.</a:t>
             </a:r>
           </a:p>
         </p:txBody>
@@ -11144,7 +11141,7 @@
                 <a:ea typeface="Calibri" pitchFamily="34" charset="-122"/>
                 <a:cs typeface="Calibri" pitchFamily="34" charset="-120"/>
               </a:rPr>
-              <a:t>Comparing KNN, Decision Tree, ANN and SVM classifiers with 2-fold cross-validation</a:t>
+              <a:t>Comparing KNN, Decision Tree, ANN, SVM and LDA classifiers with 2-fold cross-validation</a:t>
             </a:r>
             <a:endParaRPr lang="en-US" sz="2200" dirty="0"/>
           </a:p>
@@ -11706,40 +11703,7 @@
                 <a:ea typeface="Calibri" pitchFamily="34" charset="-122"/>
                 <a:cs typeface="Calibri" pitchFamily="34" charset="-120"/>
               </a:rPr>
-              <a:t>A bank account lets people save safely, borrow, insure against risk and receive payments. Across sub-Saharan Africa, only about half of adults hold any account, and far fewer hold a formal bank account (</a:t>
-            </a:r>
-            <a:r>
-              <a:rPr lang="nl-NL" sz="1550" dirty="0">
-                <a:solidFill>
-                  <a:srgbClr val="0B0B0B"/>
-                </a:solidFill>
-                <a:latin typeface="Calibri" pitchFamily="34" charset="0"/>
-                <a:ea typeface="Calibri" pitchFamily="34" charset="-122"/>
-                <a:cs typeface="Calibri" pitchFamily="34" charset="-120"/>
-              </a:rPr>
-              <a:t>Demirguc-Kunt et al, 2022</a:t>
-            </a:r>
-            <a:r>
-              <a:rPr lang="fi-FI" sz="1550" dirty="0">
-                <a:solidFill>
-                  <a:srgbClr val="0B0B0B"/>
-                </a:solidFill>
-                <a:latin typeface="Calibri" pitchFamily="34" charset="0"/>
-                <a:ea typeface="Calibri" pitchFamily="34" charset="-122"/>
-                <a:cs typeface="Calibri" pitchFamily="34" charset="-120"/>
-              </a:rPr>
-              <a:t>)</a:t>
-            </a:r>
-            <a:r>
-              <a:rPr lang="en-US" sz="1550" dirty="0">
-                <a:solidFill>
-                  <a:srgbClr val="0B0B0B"/>
-                </a:solidFill>
-                <a:latin typeface="Calibri" pitchFamily="34" charset="0"/>
-                <a:ea typeface="Calibri" pitchFamily="34" charset="-122"/>
-                <a:cs typeface="Calibri" pitchFamily="34" charset="-120"/>
-              </a:rPr>
-              <a:t>. Knowing who is excluded, and which characteristics predict exclusion, helps banks, mobile-money operators and policymakers target the right products and policy.</a:t>
+              <a:t>A bank account lets people save safely, borrow, insure against risk and receive payments. Across sub-Saharan Africa, only about half of adults hold any account, and far fewer hold a formal bank account (Demirgüç-Kunt et al., 2022). Knowing who is excluded, and which characteristics predict exclusion, helps banks, mobile-money operators and policymakers target the right products and policy.</a:t>
             </a:r>
           </a:p>
           <a:p>
@@ -11772,7 +11736,7 @@
                 <a:ea typeface="Calibri" pitchFamily="34" charset="-122"/>
                 <a:cs typeface="Calibri" pitchFamily="34" charset="-120"/>
               </a:rPr>
-              <a:t>This project tests whether four standard machine-learning methods can learn that prediction from national survey data, and which method does it best.</a:t>
+              <a:t>This project tests whether five standard machine-learning methods can learn that prediction from national survey data, and which method does it best.</a:t>
             </a:r>
             <a:endParaRPr lang="en-US" sz="1550" dirty="0"/>
           </a:p>
@@ -12725,7 +12689,7 @@
                 <a:ea typeface="Calibri" pitchFamily="34" charset="-122"/>
                 <a:cs typeface="Calibri" pitchFamily="34" charset="-120"/>
               </a:rPr>
-              <a:t>4. Comparing classic classifiers - The IJRASET 2024 comparative analysis</a:t>
+              <a:t>4. Comparing classic classifiers - Acharya &amp; Shaileshbhai (2024)</a:t>
             </a:r>
             <a:endParaRPr lang="en-US" sz="1400" dirty="0"/>
           </a:p>
@@ -13546,7 +13510,7 @@
         <p:spPr>
           <a:xfrm>
             <a:off x="640080" y="1554480"/>
-            <a:ext cx="2670048" cy="3931920"/>
+            <a:ext cx="2075688" cy="3931920"/>
           </a:xfrm>
           <a:prstGeom prst="roundRect">
             <a:avLst>
@@ -13574,7 +13538,7 @@
         </p:nvSpPr>
         <p:spPr>
           <a:xfrm>
-            <a:off x="1609344" y="1874520"/>
+            <a:off x="1312164" y="1874520"/>
             <a:ext cx="731520" cy="731520"/>
           </a:xfrm>
           <a:prstGeom prst="ellipse">
@@ -13609,7 +13573,7 @@
         </p:blipFill>
         <p:spPr>
           <a:xfrm>
-            <a:off x="1799539" y="2064715"/>
+            <a:off x="1504188" y="2064715"/>
             <a:ext cx="351130" cy="351130"/>
           </a:xfrm>
           <a:prstGeom prst="rect">
@@ -13626,7 +13590,7 @@
         <p:spPr>
           <a:xfrm>
             <a:off x="640080" y="2743200"/>
-            <a:ext cx="2670048" cy="457200"/>
+            <a:ext cx="2075688" cy="457200"/>
           </a:xfrm>
           <a:prstGeom prst="rect">
             <a:avLst/>
@@ -13664,8 +13628,8 @@
         </p:nvSpPr>
         <p:spPr>
           <a:xfrm>
-            <a:off x="868680" y="3246120"/>
-            <a:ext cx="2212848" cy="1417320"/>
+            <a:off x="777240" y="3246120"/>
+            <a:ext cx="1801368" cy="1417320"/>
           </a:xfrm>
           <a:prstGeom prst="rect">
             <a:avLst/>
@@ -13703,8 +13667,8 @@
         </p:nvSpPr>
         <p:spPr>
           <a:xfrm>
-            <a:off x="868680" y="4709160"/>
-            <a:ext cx="2212848" cy="685800"/>
+            <a:off x="777240" y="4709160"/>
+            <a:ext cx="1801368" cy="685800"/>
           </a:xfrm>
           <a:prstGeom prst="rect">
             <a:avLst/>
@@ -13742,8 +13706,8 @@
         </p:nvSpPr>
         <p:spPr>
           <a:xfrm>
-            <a:off x="3474720" y="1554480"/>
-            <a:ext cx="2670048" cy="3931920"/>
+            <a:off x="2848356" y="1554480"/>
+            <a:ext cx="2075688" cy="3931920"/>
           </a:xfrm>
           <a:prstGeom prst="roundRect">
             <a:avLst>
@@ -13771,7 +13735,7 @@
         </p:nvSpPr>
         <p:spPr>
           <a:xfrm>
-            <a:off x="4443984" y="1874520"/>
+            <a:off x="3520440" y="1874520"/>
             <a:ext cx="731520" cy="731520"/>
           </a:xfrm>
           <a:prstGeom prst="ellipse">
@@ -13806,7 +13770,7 @@
         </p:blipFill>
         <p:spPr>
           <a:xfrm>
-            <a:off x="4634179" y="2064715"/>
+            <a:off x="3712464" y="2064715"/>
             <a:ext cx="351130" cy="351130"/>
           </a:xfrm>
           <a:prstGeom prst="rect">
@@ -13822,8 +13786,8 @@
         </p:nvSpPr>
         <p:spPr>
           <a:xfrm>
-            <a:off x="3474720" y="2743200"/>
-            <a:ext cx="2670048" cy="457200"/>
+            <a:off x="2848356" y="2743200"/>
+            <a:ext cx="2075688" cy="457200"/>
           </a:xfrm>
           <a:prstGeom prst="rect">
             <a:avLst/>
@@ -13861,8 +13825,8 @@
         </p:nvSpPr>
         <p:spPr>
           <a:xfrm>
-            <a:off x="3703320" y="3246120"/>
-            <a:ext cx="2212848" cy="1417320"/>
+            <a:off x="2985516" y="3246120"/>
+            <a:ext cx="1801368" cy="1417320"/>
           </a:xfrm>
           <a:prstGeom prst="rect">
             <a:avLst/>
@@ -13900,8 +13864,8 @@
         </p:nvSpPr>
         <p:spPr>
           <a:xfrm>
-            <a:off x="3703320" y="4709160"/>
-            <a:ext cx="2212848" cy="685800"/>
+            <a:off x="2985516" y="4709160"/>
+            <a:ext cx="1801368" cy="685800"/>
           </a:xfrm>
           <a:prstGeom prst="rect">
             <a:avLst/>
@@ -13939,8 +13903,8 @@
         </p:nvSpPr>
         <p:spPr>
           <a:xfrm>
-            <a:off x="6309360" y="1554480"/>
-            <a:ext cx="2670048" cy="3931920"/>
+            <a:off x="5056632" y="1554480"/>
+            <a:ext cx="2075688" cy="3931920"/>
           </a:xfrm>
           <a:prstGeom prst="roundRect">
             <a:avLst>
@@ -13968,7 +13932,7 @@
         </p:nvSpPr>
         <p:spPr>
           <a:xfrm>
-            <a:off x="7278624" y="1874520"/>
+            <a:off x="5728716" y="1874520"/>
             <a:ext cx="731520" cy="731520"/>
           </a:xfrm>
           <a:prstGeom prst="ellipse">
@@ -14003,7 +13967,7 @@
         </p:blipFill>
         <p:spPr>
           <a:xfrm>
-            <a:off x="7468819" y="2064715"/>
+            <a:off x="5920740" y="2064715"/>
             <a:ext cx="351130" cy="351130"/>
           </a:xfrm>
           <a:prstGeom prst="rect">
@@ -14019,8 +13983,8 @@
         </p:nvSpPr>
         <p:spPr>
           <a:xfrm>
-            <a:off x="6309360" y="2743200"/>
-            <a:ext cx="2670048" cy="457200"/>
+            <a:off x="5056632" y="2743200"/>
+            <a:ext cx="2075688" cy="457200"/>
           </a:xfrm>
           <a:prstGeom prst="rect">
             <a:avLst/>
@@ -14058,8 +14022,8 @@
         </p:nvSpPr>
         <p:spPr>
           <a:xfrm>
-            <a:off x="6537960" y="3246120"/>
-            <a:ext cx="2212848" cy="1417320"/>
+            <a:off x="5193792" y="3246120"/>
+            <a:ext cx="1801368" cy="1417320"/>
           </a:xfrm>
           <a:prstGeom prst="rect">
             <a:avLst/>
@@ -14097,8 +14061,8 @@
         </p:nvSpPr>
         <p:spPr>
           <a:xfrm>
-            <a:off x="6537960" y="4709160"/>
-            <a:ext cx="2212848" cy="685800"/>
+            <a:off x="5193792" y="4709160"/>
+            <a:ext cx="1801368" cy="685800"/>
           </a:xfrm>
           <a:prstGeom prst="rect">
             <a:avLst/>
@@ -14136,8 +14100,8 @@
         </p:nvSpPr>
         <p:spPr>
           <a:xfrm>
-            <a:off x="9144000" y="1554480"/>
-            <a:ext cx="2670048" cy="3931920"/>
+            <a:off x="7264908" y="1554480"/>
+            <a:ext cx="2075688" cy="3931920"/>
           </a:xfrm>
           <a:prstGeom prst="roundRect">
             <a:avLst>
@@ -14165,14 +14129,14 @@
         </p:nvSpPr>
         <p:spPr>
           <a:xfrm>
-            <a:off x="10113264" y="1874520"/>
+            <a:off x="7936992" y="1874520"/>
             <a:ext cx="731520" cy="731520"/>
           </a:xfrm>
           <a:prstGeom prst="ellipse">
             <a:avLst/>
           </a:prstGeom>
           <a:solidFill>
-            <a:srgbClr val="EB6834"/>
+            <a:srgbClr val="2A78D6"/>
           </a:solidFill>
           <a:ln/>
         </p:spPr>
@@ -14200,7 +14164,7 @@
         </p:blipFill>
         <p:spPr>
           <a:xfrm>
-            <a:off x="10303459" y="2064715"/>
+            <a:off x="8129016" y="2064715"/>
             <a:ext cx="351130" cy="351130"/>
           </a:xfrm>
           <a:prstGeom prst="rect">
@@ -14216,8 +14180,8 @@
         </p:nvSpPr>
         <p:spPr>
           <a:xfrm>
-            <a:off x="9144000" y="2743200"/>
-            <a:ext cx="2670048" cy="457200"/>
+            <a:off x="7264908" y="2743200"/>
+            <a:ext cx="2075688" cy="457200"/>
           </a:xfrm>
           <a:prstGeom prst="rect">
             <a:avLst/>
@@ -14255,8 +14219,8 @@
         </p:nvSpPr>
         <p:spPr>
           <a:xfrm>
-            <a:off x="9372600" y="3246120"/>
-            <a:ext cx="2212848" cy="1417320"/>
+            <a:off x="7402068" y="3246120"/>
+            <a:ext cx="1801368" cy="1417320"/>
           </a:xfrm>
           <a:prstGeom prst="rect">
             <a:avLst/>
@@ -14294,8 +14258,8 @@
         </p:nvSpPr>
         <p:spPr>
           <a:xfrm>
-            <a:off x="9372600" y="4709160"/>
-            <a:ext cx="2212848" cy="685800"/>
+            <a:off x="7402068" y="4709160"/>
+            <a:ext cx="1801368" cy="685800"/>
           </a:xfrm>
           <a:prstGeom prst="rect">
             <a:avLst/>
@@ -14358,12 +14322,209 @@
                 <a:ea typeface="Calibri" pitchFamily="34" charset="-122"/>
                 <a:cs typeface="Calibri" pitchFamily="34" charset="-120"/>
               </a:rPr>
-              <a:t>Same data, same preprocessing, same 2-fold stratified cross-validation for all four models - so any accuracy difference comes down to the algorithm itself.</a:t>
+              <a:t>Same data, same preprocessing, same 2-fold stratified cross-validation for all five models - so any accuracy difference comes down to the algorithm itself.</a:t>
             </a:r>
             <a:endParaRPr lang="en-US" sz="1400" dirty="0"/>
           </a:p>
         </p:txBody>
       </p:sp>
+      <p:sp>
+        <p:nvSpPr>
+          <p:cNvPr id="28" name="LDA_28"/>
+          <p:cNvSpPr/>
+          <p:nvPr/>
+        </p:nvSpPr>
+        <p:spPr>
+          <a:xfrm>
+            <a:off x="9473184" y="1554480"/>
+            <a:ext cx="2075688" cy="3931920"/>
+          </a:xfrm>
+          <a:prstGeom prst="roundRect">
+            <a:avLst>
+              <a:gd name="adj" fmla="val 3425"/>
+            </a:avLst>
+          </a:prstGeom>
+          <a:solidFill>
+            <a:srgbClr val="F2F5FB"/>
+          </a:solidFill>
+          <a:ln/>
+        </p:spPr>
+        <p:txBody>
+          <a:bodyPr/>
+          <a:lstStyle/>
+          <a:p>
+            <a:endParaRPr lang="en-GB"/>
+          </a:p>
+        </p:txBody>
+      </p:sp>
+      <p:sp>
+        <p:nvSpPr>
+          <p:cNvPr id="29" name="LDA_29"/>
+          <p:cNvSpPr/>
+          <p:nvPr/>
+        </p:nvSpPr>
+        <p:spPr>
+          <a:xfrm>
+            <a:off x="10145267" y="1874520"/>
+            <a:ext cx="731520" cy="731520"/>
+          </a:xfrm>
+          <a:prstGeom prst="ellipse">
+            <a:avLst/>
+          </a:prstGeom>
+          <a:solidFill>
+            <a:srgbClr val="EB6834"/>
+          </a:solidFill>
+          <a:ln/>
+        </p:spPr>
+        <p:txBody>
+          <a:bodyPr/>
+          <a:lstStyle/>
+          <a:p>
+            <a:endParaRPr lang="en-GB"/>
+          </a:p>
+        </p:txBody>
+      </p:sp>
+      <p:sp>
+        <p:nvSpPr>
+          <p:cNvPr id="30" name="LDA_30"/>
+          <p:cNvSpPr/>
+          <p:nvPr/>
+        </p:nvSpPr>
+        <p:spPr>
+          <a:xfrm>
+            <a:off x="9473184" y="2743200"/>
+            <a:ext cx="2075688" cy="457200"/>
+          </a:xfrm>
+          <a:prstGeom prst="rect">
+            <a:avLst/>
+          </a:prstGeom>
+          <a:noFill/>
+          <a:ln/>
+        </p:spPr>
+        <p:txBody>
+          <a:bodyPr wrap="square" lIns="0" tIns="0" rIns="0" bIns="0" rtlCol="0" anchor="ctr"/>
+          <a:lstStyle/>
+          <a:p>
+            <a:pPr marL="0" indent="0" algn="ctr">
+              <a:buNone/>
+            </a:pPr>
+            <a:r>
+              <a:rPr lang="en-US" sz="1900" b="1" dirty="0">
+                <a:solidFill>
+                  <a:srgbClr val="1E2761"/>
+                </a:solidFill>
+                <a:latin typeface="Calibri" pitchFamily="34" charset="0"/>
+                <a:ea typeface="Calibri" pitchFamily="34" charset="-122"/>
+                <a:cs typeface="Calibri" pitchFamily="34" charset="-120"/>
+              </a:rPr>
+              <a:t>LDA</a:t>
+            </a:r>
+            <a:endParaRPr lang="en-US" sz="1900" dirty="0"/>
+          </a:p>
+        </p:txBody>
+      </p:sp>
+      <p:sp>
+        <p:nvSpPr>
+          <p:cNvPr id="31" name="LDA_31"/>
+          <p:cNvSpPr/>
+          <p:nvPr/>
+        </p:nvSpPr>
+        <p:spPr>
+          <a:xfrm>
+            <a:off x="9610344" y="3246120"/>
+            <a:ext cx="1801368" cy="1417320"/>
+          </a:xfrm>
+          <a:prstGeom prst="rect">
+            <a:avLst/>
+          </a:prstGeom>
+          <a:noFill/>
+          <a:ln/>
+        </p:spPr>
+        <p:txBody>
+          <a:bodyPr wrap="square" lIns="0" tIns="0" rIns="0" bIns="0" rtlCol="0" anchor="t"/>
+          <a:lstStyle/>
+          <a:p>
+            <a:pPr marL="0" indent="0" algn="ctr">
+              <a:buNone/>
+            </a:pPr>
+            <a:r>
+              <a:rPr lang="en-US" sz="1250" dirty="0">
+                <a:solidFill>
+                  <a:srgbClr val="0B0B0B"/>
+                </a:solidFill>
+                <a:latin typeface="Calibri" pitchFamily="34" charset="0"/>
+                <a:ea typeface="Calibri" pitchFamily="34" charset="-122"/>
+                <a:cs typeface="Calibri" pitchFamily="34" charset="-120"/>
+              </a:rPr>
+              <a:t>Finds the straight line that best separates the two classes.</a:t>
+            </a:r>
+            <a:endParaRPr lang="en-US" sz="1250" dirty="0"/>
+          </a:p>
+        </p:txBody>
+      </p:sp>
+      <p:sp>
+        <p:nvSpPr>
+          <p:cNvPr id="32" name="LDA_32"/>
+          <p:cNvSpPr/>
+          <p:nvPr/>
+        </p:nvSpPr>
+        <p:spPr>
+          <a:xfrm>
+            <a:off x="9610344" y="4709160"/>
+            <a:ext cx="1801368" cy="685800"/>
+          </a:xfrm>
+          <a:prstGeom prst="rect">
+            <a:avLst/>
+          </a:prstGeom>
+          <a:noFill/>
+          <a:ln/>
+        </p:spPr>
+        <p:txBody>
+          <a:bodyPr wrap="square" lIns="0" tIns="0" rIns="0" bIns="0" rtlCol="0" anchor="t"/>
+          <a:lstStyle/>
+          <a:p>
+            <a:pPr marL="0" indent="0" algn="ctr">
+              <a:buNone/>
+            </a:pPr>
+            <a:r>
+              <a:rPr lang="en-US" sz="1100" i="1" dirty="0">
+                <a:solidFill>
+                  <a:srgbClr val="5E5D59"/>
+                </a:solidFill>
+                <a:latin typeface="Calibri" pitchFamily="34" charset="0"/>
+                <a:ea typeface="Calibri" pitchFamily="34" charset="-122"/>
+                <a:cs typeface="Calibri" pitchFamily="34" charset="-120"/>
+              </a:rPr>
+              <a:t>solver = svd, no tuning needed</a:t>
+            </a:r>
+            <a:endParaRPr lang="en-US" sz="1100" dirty="0"/>
+          </a:p>
+        </p:txBody>
+      </p:sp>
+      <p:pic>
+        <p:nvPicPr>
+          <p:cNvPr id="33" name="Picture 32" descr="chartline.png"/>
+          <p:cNvPicPr>
+            <a:picLocks noChangeAspect="1"/>
+          </p:cNvPicPr>
+          <p:nvPr/>
+        </p:nvPicPr>
+        <p:blipFill>
+          <a:blip r:embed="rId7"/>
+          <a:stretch>
+            <a:fillRect/>
+          </a:stretch>
+        </p:blipFill>
+        <p:spPr>
+          <a:xfrm>
+            <a:off x="10337292" y="2066543"/>
+            <a:ext cx="347472" cy="347472"/>
+          </a:xfrm>
+          <a:prstGeom prst="rect">
+            <a:avLst/>
+          </a:prstGeom>
+        </p:spPr>
+      </p:pic>
     </p:spTree>
   </p:cSld>
   <p:clrMapOvr>
@@ -14603,18 +14764,7 @@
                 <a:ea typeface="Calibri" pitchFamily="34" charset="-122"/>
                 <a:cs typeface="Calibri" pitchFamily="34" charset="-120"/>
               </a:rPr>
-              <a:t>The benchmark is 85.9%.  </a:t>
-            </a:r>
-            <a:r>
-              <a:rPr lang="en-US" sz="1250" dirty="0">
-                <a:solidFill>
-                  <a:srgbClr val="0B0B0B"/>
-                </a:solidFill>
-                <a:latin typeface="Calibri" pitchFamily="34" charset="0"/>
-                <a:ea typeface="Calibri" pitchFamily="34" charset="-122"/>
-                <a:cs typeface="Calibri" pitchFamily="34" charset="-120"/>
-              </a:rPr>
-              <a:t>Always answering “No account” scores 85.9%; All 4 models beat the benchmark, but by at most 2.9 points.</a:t>
+              <a:t>The benchmark is 85.9%.  Always answering “No account” scores 85.9%; All 5 models beat the benchmark, but by at most 2.9 points.</a:t>
             </a:r>
             <a:endParaRPr lang="en-US" sz="1250" dirty="0"/>
           </a:p>
@@ -14707,7 +14857,7 @@
           </p:nvPr>
         </p:nvGraphicFramePr>
         <p:xfrm>
-          <a:off x="640080" y="1554480"/>
+          <a:off x="640080" y="1371600"/>
           <a:ext cx="10881360" cy="2834640"/>
         </p:xfrm>
         <a:graphic>
@@ -14765,7 +14915,7 @@
                   </a:extLst>
                 </a:gridCol>
               </a:tblGrid>
-              <a:tr h="566928">
+              <a:tr h="420624">
                 <a:tc>
                   <a:txBody>
                     <a:bodyPr/>
@@ -15248,7 +15398,7 @@
                   </a:ext>
                 </a:extLst>
               </a:tr>
-              <a:tr h="566928">
+              <a:tr h="420624">
                 <a:tc>
                   <a:txBody>
                     <a:bodyPr/>
@@ -15731,7 +15881,7 @@
                   </a:ext>
                 </a:extLst>
               </a:tr>
-              <a:tr h="566928">
+              <a:tr h="420624">
                 <a:tc>
                   <a:txBody>
                     <a:bodyPr/>
@@ -16214,7 +16364,7 @@
                   </a:ext>
                 </a:extLst>
               </a:tr>
-              <a:tr h="566928">
+              <a:tr h="420624">
                 <a:tc>
                   <a:txBody>
                     <a:bodyPr/>
@@ -16697,7 +16847,7 @@
                   </a:ext>
                 </a:extLst>
               </a:tr>
-              <a:tr h="566928">
+              <a:tr h="420624">
                 <a:tc>
                   <a:txBody>
                     <a:bodyPr/>
@@ -17180,6 +17330,489 @@
                   </a:ext>
                 </a:extLst>
               </a:tr>
+              <a:tr h="420624">
+                <a:tc>
+                  <a:txBody>
+                    <a:bodyPr/>
+                    <a:lstStyle/>
+                    <a:p>
+                      <a:pPr marL="0" indent="0" algn="l">
+                        <a:buNone/>
+                      </a:pPr>
+                      <a:r>
+                        <a:rPr lang="en-US" sz="1400" b="1" dirty="0">
+                          <a:solidFill>
+                            <a:srgbClr val="1E2761"/>
+                          </a:solidFill>
+                          <a:latin typeface="Calibri" pitchFamily="34" charset="0"/>
+                          <a:ea typeface="Calibri" pitchFamily="34" charset="-122"/>
+                          <a:cs typeface="Calibri" pitchFamily="34" charset="-120"/>
+                        </a:rPr>
+                        <a:t>LDA</a:t>
+                      </a:r>
+                      <a:endParaRPr lang="en-US" sz="1400" dirty="0">
+                        <a:latin typeface="Calibri" charset="0"/>
+                        <a:ea typeface="Calibri" charset="0"/>
+                        <a:cs typeface="Calibri" charset="0"/>
+                      </a:endParaRPr>
+                    </a:p>
+                  </a:txBody>
+                  <a:tcPr anchor="ctr">
+                    <a:lnL w="9525" cap="flat" cmpd="sng" algn="ctr">
+                      <a:solidFill>
+                        <a:srgbClr val="D8DCE6"/>
+                      </a:solidFill>
+                      <a:prstDash val="solid"/>
+                      <a:round/>
+                      <a:headEnd type="none" w="med" len="med"/>
+                      <a:tailEnd type="none" w="med" len="med"/>
+                    </a:lnL>
+                    <a:lnR w="9525" cap="flat" cmpd="sng" algn="ctr">
+                      <a:solidFill>
+                        <a:srgbClr val="D8DCE6"/>
+                      </a:solidFill>
+                      <a:prstDash val="solid"/>
+                      <a:round/>
+                      <a:headEnd type="none" w="med" len="med"/>
+                      <a:tailEnd type="none" w="med" len="med"/>
+                    </a:lnR>
+                    <a:lnT w="9525" cap="flat" cmpd="sng" algn="ctr">
+                      <a:solidFill>
+                        <a:srgbClr val="D8DCE6"/>
+                      </a:solidFill>
+                      <a:prstDash val="solid"/>
+                      <a:round/>
+                      <a:headEnd type="none" w="med" len="med"/>
+                      <a:tailEnd type="none" w="med" len="med"/>
+                    </a:lnT>
+                    <a:lnB w="9525" cap="flat" cmpd="sng" algn="ctr">
+                      <a:solidFill>
+                        <a:srgbClr val="D8DCE6"/>
+                      </a:solidFill>
+                      <a:prstDash val="solid"/>
+                      <a:round/>
+                      <a:headEnd type="none" w="med" len="med"/>
+                      <a:tailEnd type="none" w="med" len="med"/>
+                    </a:lnB>
+                    <a:solidFill>
+                      <a:srgbClr val="FFFFFF"/>
+                    </a:solidFill>
+                  </a:tcPr>
+                </a:tc>
+                <a:tc>
+                  <a:txBody>
+                    <a:bodyPr/>
+                    <a:lstStyle/>
+                    <a:p>
+                      <a:pPr marL="0" indent="0" algn="ctr">
+                        <a:buNone/>
+                      </a:pPr>
+                      <a:r>
+                        <a:rPr lang="en-US" sz="1400" dirty="0">
+                          <a:solidFill>
+                            <a:srgbClr val="0B0B0B"/>
+                          </a:solidFill>
+                          <a:latin typeface="Calibri" pitchFamily="34" charset="0"/>
+                          <a:ea typeface="Calibri" pitchFamily="34" charset="-122"/>
+                          <a:cs typeface="Calibri" pitchFamily="34" charset="-120"/>
+                        </a:rPr>
+                        <a:t>0.8796</a:t>
+                      </a:r>
+                      <a:endParaRPr lang="en-US" sz="1400" dirty="0">
+                        <a:latin typeface="Calibri" charset="0"/>
+                        <a:ea typeface="Calibri" charset="0"/>
+                        <a:cs typeface="Calibri" charset="0"/>
+                      </a:endParaRPr>
+                    </a:p>
+                  </a:txBody>
+                  <a:tcPr anchor="ctr">
+                    <a:lnL w="9525" cap="flat" cmpd="sng" algn="ctr">
+                      <a:solidFill>
+                        <a:srgbClr val="D8DCE6"/>
+                      </a:solidFill>
+                      <a:prstDash val="solid"/>
+                      <a:round/>
+                      <a:headEnd type="none" w="med" len="med"/>
+                      <a:tailEnd type="none" w="med" len="med"/>
+                    </a:lnL>
+                    <a:lnR w="9525" cap="flat" cmpd="sng" algn="ctr">
+                      <a:solidFill>
+                        <a:srgbClr val="D8DCE6"/>
+                      </a:solidFill>
+                      <a:prstDash val="solid"/>
+                      <a:round/>
+                      <a:headEnd type="none" w="med" len="med"/>
+                      <a:tailEnd type="none" w="med" len="med"/>
+                    </a:lnR>
+                    <a:lnT w="9525" cap="flat" cmpd="sng" algn="ctr">
+                      <a:solidFill>
+                        <a:srgbClr val="D8DCE6"/>
+                      </a:solidFill>
+                      <a:prstDash val="solid"/>
+                      <a:round/>
+                      <a:headEnd type="none" w="med" len="med"/>
+                      <a:tailEnd type="none" w="med" len="med"/>
+                    </a:lnT>
+                    <a:lnB w="9525" cap="flat" cmpd="sng" algn="ctr">
+                      <a:solidFill>
+                        <a:srgbClr val="D8DCE6"/>
+                      </a:solidFill>
+                      <a:prstDash val="solid"/>
+                      <a:round/>
+                      <a:headEnd type="none" w="med" len="med"/>
+                      <a:tailEnd type="none" w="med" len="med"/>
+                    </a:lnB>
+                    <a:solidFill>
+                      <a:srgbClr val="FFFFFF"/>
+                    </a:solidFill>
+                  </a:tcPr>
+                </a:tc>
+                <a:tc>
+                  <a:txBody>
+                    <a:bodyPr/>
+                    <a:lstStyle/>
+                    <a:p>
+                      <a:pPr marL="0" indent="0" algn="ctr">
+                        <a:buNone/>
+                      </a:pPr>
+                      <a:r>
+                        <a:rPr lang="en-US" sz="1400" dirty="0">
+                          <a:solidFill>
+                            <a:srgbClr val="0B0B0B"/>
+                          </a:solidFill>
+                          <a:latin typeface="Calibri" pitchFamily="34" charset="0"/>
+                          <a:ea typeface="Calibri" pitchFamily="34" charset="-122"/>
+                          <a:cs typeface="Calibri" pitchFamily="34" charset="-120"/>
+                        </a:rPr>
+                        <a:t>0.8808</a:t>
+                      </a:r>
+                      <a:endParaRPr lang="en-US" sz="1400" dirty="0">
+                        <a:latin typeface="Calibri" charset="0"/>
+                        <a:ea typeface="Calibri" charset="0"/>
+                        <a:cs typeface="Calibri" charset="0"/>
+                      </a:endParaRPr>
+                    </a:p>
+                  </a:txBody>
+                  <a:tcPr anchor="ctr">
+                    <a:lnL w="9525" cap="flat" cmpd="sng" algn="ctr">
+                      <a:solidFill>
+                        <a:srgbClr val="D8DCE6"/>
+                      </a:solidFill>
+                      <a:prstDash val="solid"/>
+                      <a:round/>
+                      <a:headEnd type="none" w="med" len="med"/>
+                      <a:tailEnd type="none" w="med" len="med"/>
+                    </a:lnL>
+                    <a:lnR w="9525" cap="flat" cmpd="sng" algn="ctr">
+                      <a:solidFill>
+                        <a:srgbClr val="D8DCE6"/>
+                      </a:solidFill>
+                      <a:prstDash val="solid"/>
+                      <a:round/>
+                      <a:headEnd type="none" w="med" len="med"/>
+                      <a:tailEnd type="none" w="med" len="med"/>
+                    </a:lnR>
+                    <a:lnT w="9525" cap="flat" cmpd="sng" algn="ctr">
+                      <a:solidFill>
+                        <a:srgbClr val="D8DCE6"/>
+                      </a:solidFill>
+                      <a:prstDash val="solid"/>
+                      <a:round/>
+                      <a:headEnd type="none" w="med" len="med"/>
+                      <a:tailEnd type="none" w="med" len="med"/>
+                    </a:lnT>
+                    <a:lnB w="9525" cap="flat" cmpd="sng" algn="ctr">
+                      <a:solidFill>
+                        <a:srgbClr val="D8DCE6"/>
+                      </a:solidFill>
+                      <a:prstDash val="solid"/>
+                      <a:round/>
+                      <a:headEnd type="none" w="med" len="med"/>
+                      <a:tailEnd type="none" w="med" len="med"/>
+                    </a:lnB>
+                    <a:solidFill>
+                      <a:srgbClr val="FFFFFF"/>
+                    </a:solidFill>
+                  </a:tcPr>
+                </a:tc>
+                <a:tc>
+                  <a:txBody>
+                    <a:bodyPr/>
+                    <a:lstStyle/>
+                    <a:p>
+                      <a:pPr marL="0" indent="0" algn="ctr">
+                        <a:buNone/>
+                      </a:pPr>
+                      <a:r>
+                        <a:rPr lang="en-US" sz="1400" b="1" dirty="0">
+                          <a:solidFill>
+                            <a:srgbClr val="0B0B0B"/>
+                          </a:solidFill>
+                          <a:latin typeface="Calibri" pitchFamily="34" charset="0"/>
+                          <a:ea typeface="Calibri" pitchFamily="34" charset="-122"/>
+                          <a:cs typeface="Calibri" pitchFamily="34" charset="-120"/>
+                        </a:rPr>
+                        <a:t>0.8802</a:t>
+                      </a:r>
+                      <a:endParaRPr lang="en-US" sz="1400" dirty="0">
+                        <a:latin typeface="Calibri" charset="0"/>
+                        <a:ea typeface="Calibri" charset="0"/>
+                        <a:cs typeface="Calibri" charset="0"/>
+                      </a:endParaRPr>
+                    </a:p>
+                  </a:txBody>
+                  <a:tcPr anchor="ctr">
+                    <a:lnL w="9525" cap="flat" cmpd="sng" algn="ctr">
+                      <a:solidFill>
+                        <a:srgbClr val="D8DCE6"/>
+                      </a:solidFill>
+                      <a:prstDash val="solid"/>
+                      <a:round/>
+                      <a:headEnd type="none" w="med" len="med"/>
+                      <a:tailEnd type="none" w="med" len="med"/>
+                    </a:lnL>
+                    <a:lnR w="9525" cap="flat" cmpd="sng" algn="ctr">
+                      <a:solidFill>
+                        <a:srgbClr val="D8DCE6"/>
+                      </a:solidFill>
+                      <a:prstDash val="solid"/>
+                      <a:round/>
+                      <a:headEnd type="none" w="med" len="med"/>
+                      <a:tailEnd type="none" w="med" len="med"/>
+                    </a:lnR>
+                    <a:lnT w="9525" cap="flat" cmpd="sng" algn="ctr">
+                      <a:solidFill>
+                        <a:srgbClr val="D8DCE6"/>
+                      </a:solidFill>
+                      <a:prstDash val="solid"/>
+                      <a:round/>
+                      <a:headEnd type="none" w="med" len="med"/>
+                      <a:tailEnd type="none" w="med" len="med"/>
+                    </a:lnT>
+                    <a:lnB w="9525" cap="flat" cmpd="sng" algn="ctr">
+                      <a:solidFill>
+                        <a:srgbClr val="D8DCE6"/>
+                      </a:solidFill>
+                      <a:prstDash val="solid"/>
+                      <a:round/>
+                      <a:headEnd type="none" w="med" len="med"/>
+                      <a:tailEnd type="none" w="med" len="med"/>
+                    </a:lnB>
+                    <a:solidFill>
+                      <a:srgbClr val="FFFFFF"/>
+                    </a:solidFill>
+                  </a:tcPr>
+                </a:tc>
+                <a:tc>
+                  <a:txBody>
+                    <a:bodyPr/>
+                    <a:lstStyle/>
+                    <a:p>
+                      <a:pPr marL="0" indent="0" algn="ctr">
+                        <a:buNone/>
+                      </a:pPr>
+                      <a:r>
+                        <a:rPr lang="en-US" sz="1400" dirty="0">
+                          <a:solidFill>
+                            <a:srgbClr val="0B0B0B"/>
+                          </a:solidFill>
+                          <a:latin typeface="Calibri" pitchFamily="34" charset="0"/>
+                          <a:ea typeface="Calibri" pitchFamily="34" charset="-122"/>
+                          <a:cs typeface="Calibri" pitchFamily="34" charset="-120"/>
+                        </a:rPr>
+                        <a:t>0.8808</a:t>
+                      </a:r>
+                      <a:endParaRPr lang="en-US" sz="1400" dirty="0">
+                        <a:latin typeface="Calibri" charset="0"/>
+                        <a:ea typeface="Calibri" charset="0"/>
+                        <a:cs typeface="Calibri" charset="0"/>
+                      </a:endParaRPr>
+                    </a:p>
+                  </a:txBody>
+                  <a:tcPr anchor="ctr">
+                    <a:lnL w="9525" cap="flat" cmpd="sng" algn="ctr">
+                      <a:solidFill>
+                        <a:srgbClr val="D8DCE6"/>
+                      </a:solidFill>
+                      <a:prstDash val="solid"/>
+                      <a:round/>
+                      <a:headEnd type="none" w="med" len="med"/>
+                      <a:tailEnd type="none" w="med" len="med"/>
+                    </a:lnL>
+                    <a:lnR w="9525" cap="flat" cmpd="sng" algn="ctr">
+                      <a:solidFill>
+                        <a:srgbClr val="D8DCE6"/>
+                      </a:solidFill>
+                      <a:prstDash val="solid"/>
+                      <a:round/>
+                      <a:headEnd type="none" w="med" len="med"/>
+                      <a:tailEnd type="none" w="med" len="med"/>
+                    </a:lnR>
+                    <a:lnT w="9525" cap="flat" cmpd="sng" algn="ctr">
+                      <a:solidFill>
+                        <a:srgbClr val="D8DCE6"/>
+                      </a:solidFill>
+                      <a:prstDash val="solid"/>
+                      <a:round/>
+                      <a:headEnd type="none" w="med" len="med"/>
+                      <a:tailEnd type="none" w="med" len="med"/>
+                    </a:lnT>
+                    <a:lnB w="9525" cap="flat" cmpd="sng" algn="ctr">
+                      <a:solidFill>
+                        <a:srgbClr val="D8DCE6"/>
+                      </a:solidFill>
+                      <a:prstDash val="solid"/>
+                      <a:round/>
+                      <a:headEnd type="none" w="med" len="med"/>
+                      <a:tailEnd type="none" w="med" len="med"/>
+                    </a:lnB>
+                    <a:solidFill>
+                      <a:srgbClr val="FFFFFF"/>
+                    </a:solidFill>
+                  </a:tcPr>
+                </a:tc>
+                <a:tc>
+                  <a:txBody>
+                    <a:bodyPr/>
+                    <a:lstStyle/>
+                    <a:p>
+                      <a:pPr marL="0" indent="0" algn="ctr">
+                        <a:buNone/>
+                      </a:pPr>
+                      <a:r>
+                        <a:rPr lang="en-US" sz="1400" dirty="0">
+                          <a:solidFill>
+                            <a:srgbClr val="0B0B0B"/>
+                          </a:solidFill>
+                          <a:latin typeface="Calibri" pitchFamily="34" charset="0"/>
+                          <a:ea typeface="Calibri" pitchFamily="34" charset="-122"/>
+                          <a:cs typeface="Calibri" pitchFamily="34" charset="-120"/>
+                        </a:rPr>
+                        <a:t>0.0006</a:t>
+                      </a:r>
+                      <a:endParaRPr lang="en-US" sz="1400" dirty="0">
+                        <a:latin typeface="Calibri" charset="0"/>
+                        <a:ea typeface="Calibri" charset="0"/>
+                        <a:cs typeface="Calibri" charset="0"/>
+                      </a:endParaRPr>
+                    </a:p>
+                  </a:txBody>
+                  <a:tcPr anchor="ctr">
+                    <a:lnL w="9525" cap="flat" cmpd="sng" algn="ctr">
+                      <a:solidFill>
+                        <a:srgbClr val="D8DCE6"/>
+                      </a:solidFill>
+                      <a:prstDash val="solid"/>
+                      <a:round/>
+                      <a:headEnd type="none" w="med" len="med"/>
+                      <a:tailEnd type="none" w="med" len="med"/>
+                    </a:lnL>
+                    <a:lnR w="9525" cap="flat" cmpd="sng" algn="ctr">
+                      <a:solidFill>
+                        <a:srgbClr val="D8DCE6"/>
+                      </a:solidFill>
+                      <a:prstDash val="solid"/>
+                      <a:round/>
+                      <a:headEnd type="none" w="med" len="med"/>
+                      <a:tailEnd type="none" w="med" len="med"/>
+                    </a:lnR>
+                    <a:lnT w="9525" cap="flat" cmpd="sng" algn="ctr">
+                      <a:solidFill>
+                        <a:srgbClr val="D8DCE6"/>
+                      </a:solidFill>
+                      <a:prstDash val="solid"/>
+                      <a:round/>
+                      <a:headEnd type="none" w="med" len="med"/>
+                      <a:tailEnd type="none" w="med" len="med"/>
+                    </a:lnT>
+                    <a:lnB w="9525" cap="flat" cmpd="sng" algn="ctr">
+                      <a:solidFill>
+                        <a:srgbClr val="D8DCE6"/>
+                      </a:solidFill>
+                      <a:prstDash val="solid"/>
+                      <a:round/>
+                      <a:headEnd type="none" w="med" len="med"/>
+                      <a:tailEnd type="none" w="med" len="med"/>
+                    </a:lnB>
+                    <a:solidFill>
+                      <a:srgbClr val="FFFFFF"/>
+                    </a:solidFill>
+                  </a:tcPr>
+                </a:tc>
+                <a:tc>
+                  <a:txBody>
+                    <a:bodyPr/>
+                    <a:lstStyle/>
+                    <a:p>
+                      <a:pPr marL="0" indent="0" algn="ctr">
+                        <a:buNone/>
+                      </a:pPr>
+                      <a:r>
+                        <a:rPr lang="en-US" sz="1400" dirty="0">
+                          <a:solidFill>
+                            <a:srgbClr val="0B0B0B"/>
+                          </a:solidFill>
+                          <a:latin typeface="Calibri" pitchFamily="34" charset="0"/>
+                          <a:ea typeface="Calibri" pitchFamily="34" charset="-122"/>
+                          <a:cs typeface="Calibri" pitchFamily="34" charset="-120"/>
+                        </a:rPr>
+                        <a:t>0.3</a:t>
+                      </a:r>
+                      <a:endParaRPr lang="en-US" sz="1400" dirty="0">
+                        <a:latin typeface="Calibri" charset="0"/>
+                        <a:ea typeface="Calibri" charset="0"/>
+                        <a:cs typeface="Calibri" charset="0"/>
+                      </a:endParaRPr>
+                    </a:p>
+                  </a:txBody>
+                  <a:tcPr anchor="ctr">
+                    <a:lnL w="9525" cap="flat" cmpd="sng" algn="ctr">
+                      <a:solidFill>
+                        <a:srgbClr val="D8DCE6"/>
+                      </a:solidFill>
+                      <a:prstDash val="solid"/>
+                      <a:round/>
+                      <a:headEnd type="none" w="med" len="med"/>
+                      <a:tailEnd type="none" w="med" len="med"/>
+                    </a:lnL>
+                    <a:lnR w="9525" cap="flat" cmpd="sng" algn="ctr">
+                      <a:solidFill>
+                        <a:srgbClr val="D8DCE6"/>
+                      </a:solidFill>
+                      <a:prstDash val="solid"/>
+                      <a:round/>
+                      <a:headEnd type="none" w="med" len="med"/>
+                      <a:tailEnd type="none" w="med" len="med"/>
+                    </a:lnR>
+                    <a:lnT w="9525" cap="flat" cmpd="sng" algn="ctr">
+                      <a:solidFill>
+                        <a:srgbClr val="D8DCE6"/>
+                      </a:solidFill>
+                      <a:prstDash val="solid"/>
+                      <a:round/>
+                      <a:headEnd type="none" w="med" len="med"/>
+                      <a:tailEnd type="none" w="med" len="med"/>
+                    </a:lnT>
+                    <a:lnB w="9525" cap="flat" cmpd="sng" algn="ctr">
+                      <a:solidFill>
+                        <a:srgbClr val="D8DCE6"/>
+                      </a:solidFill>
+                      <a:prstDash val="solid"/>
+                      <a:round/>
+                      <a:headEnd type="none" w="med" len="med"/>
+                      <a:tailEnd type="none" w="med" len="med"/>
+                    </a:lnB>
+                    <a:solidFill>
+                      <a:srgbClr val="FFFFFF"/>
+                    </a:solidFill>
+                  </a:tcPr>
+                </a:tc>
+                <a:extLst>
+                  <a:ext uri="{0D108BD9-81ED-4DB2-BD59-A6C34878D82A}">
+                    <a16:rowId xmlns:a16="http://schemas.microsoft.com/office/drawing/2014/main" val="10003"/>
+                  </a:ext>
+                </a:extLst>
+              </a:tr>
             </a:tbl>
           </a:graphicData>
         </a:graphic>
@@ -17382,7 +18015,7 @@
                 <a:ea typeface="Calibri" pitchFamily="34" charset="-122"/>
                 <a:cs typeface="Calibri" pitchFamily="34" charset="-120"/>
               </a:rPr>
-              <a:t>All four models cluster within 1.5 points of each other under CV; the confusion matrices (next slide) separate them further.</a:t>
+              <a:t>All five models cluster within 1.5 points of each other under CV; the confusion matrices (next slide) separate them further.</a:t>
             </a:r>
             <a:endParaRPr lang="en-US" sz="1150" dirty="0"/>
           </a:p>
@@ -17658,7 +18291,7 @@
                 <a:ea typeface="Calibri" pitchFamily="34" charset="-122"/>
                 <a:cs typeface="Calibri" pitchFamily="34" charset="-120"/>
               </a:rPr>
-              <a:t>Every model recognizes non-account-holders almost perfectly (96-98%) but finds only 30-35% of actual account holders.</a:t>
+              <a:t>Every model recognizes non-account-holders almost perfectly (96-98%) but finds only 30-39% of actual account holders.</a:t>
             </a:r>
             <a:endParaRPr lang="en-US" sz="1150" dirty="0"/>
           </a:p>
@@ -17736,7 +18369,7 @@
                 <a:ea typeface="Calibri" pitchFamily="34" charset="-122"/>
                 <a:cs typeface="Calibri" pitchFamily="34" charset="-120"/>
               </a:rPr>
-              <a:t>SVM is the most conservative (fewest false “Yes”: 328) yet misses the most real account holders; ANN finds the most (1,175). Which is “best” depends on the cost of each error.</a:t>
+              <a:t>SVM is the most conservative (fewest false “Yes”: 328) yet misses the most real account holders; LDA finds the most (1,290). Which is “best” depends on the cost of each error.</a:t>
             </a:r>
             <a:endParaRPr lang="en-US" sz="1150" dirty="0"/>
           </a:p>

</xml_diff>